<commit_message>
Translate documentation to English
</commit_message>
<xml_diff>
--- a/OCI_Streaming_HA_Architecture.pptx
+++ b/OCI_Streaming_HA_Architecture.pptx
@@ -2,112 +2,17 @@
 <file path=ppt/presentation.xml><?xml version="1.0" encoding="utf-8"?>
 <p:presentation xmlns:p="http://schemas.openxmlformats.org/presentationml/2006/main">
   <p:sldMasterIdLst>
-    <p:sldMasterId xmlns:r="http://schemas.openxmlformats.org/officeDocument/2006/relationships" id="2147483648" r:id="R13d297b611e54db9"/>
+    <p:sldMasterId xmlns:r="http://schemas.openxmlformats.org/officeDocument/2006/relationships" id="2147483648" r:id="R9569179f11b94211"/>
   </p:sldMasterIdLst>
   <p:notesMasterIdLst>
-    <p:notesMasterId xmlns:r="http://schemas.openxmlformats.org/officeDocument/2006/relationships" r:id="R026c5dafc2b2459a"/>
+    <p:notesMasterId xmlns:r="http://schemas.openxmlformats.org/officeDocument/2006/relationships" r:id="Rdcfbaa30dfab4680"/>
   </p:notesMasterIdLst>
   <p:sldIdLst>
-    <p:sldId xmlns:r="http://schemas.openxmlformats.org/officeDocument/2006/relationships" id="256" r:id="Ra5e261d87a714d3e"/>
-    <p:sldId xmlns:r="http://schemas.openxmlformats.org/officeDocument/2006/relationships" id="257" r:id="R4e2062381cf0453b"/>
+    <p:sldId xmlns:r="http://schemas.openxmlformats.org/officeDocument/2006/relationships" id="256" r:id="Raef7b2f9ce1c4493"/>
+    <p:sldId xmlns:r="http://schemas.openxmlformats.org/officeDocument/2006/relationships" id="257" r:id="R797e786b3a23477f"/>
   </p:sldIdLst>
   <p:sldSz cx="15240000" cy="8572500"/>
   <p:notesSz cx="6858000" cy="9144000"/>
-  <p:defaultTextStyle>
-    <a:defPPr xmlns:a="http://schemas.openxmlformats.org/drawingml/2006/main">
-      <a:defRPr lang="en-US"/>
-    </a:defPPr>
-    <a:lvl1pPr xmlns:a="http://schemas.openxmlformats.org/drawingml/2006/main" marL="0" indent="0" algn="l" defTabSz="914400">
-      <a:defRPr sz="1800" kern="1200">
-        <a:solidFill>
-          <a:schemeClr val="tx1"/>
-        </a:solidFill>
-        <a:latin typeface="+mn-lt"/>
-        <a:ea typeface="+mn-ea"/>
-        <a:cs typeface="+mn-cs"/>
-      </a:defRPr>
-    </a:lvl1pPr>
-    <a:lvl2pPr xmlns:a="http://schemas.openxmlformats.org/drawingml/2006/main" marL="457200" indent="0" algn="l" defTabSz="914400">
-      <a:defRPr sz="1800" kern="1200">
-        <a:solidFill>
-          <a:schemeClr val="tx1"/>
-        </a:solidFill>
-        <a:latin typeface="+mn-lt"/>
-        <a:ea typeface="+mn-ea"/>
-        <a:cs typeface="+mn-cs"/>
-      </a:defRPr>
-    </a:lvl2pPr>
-    <a:lvl3pPr xmlns:a="http://schemas.openxmlformats.org/drawingml/2006/main" marL="914400" indent="0" algn="l" defTabSz="914400">
-      <a:defRPr sz="1800" kern="1200">
-        <a:solidFill>
-          <a:schemeClr val="tx1"/>
-        </a:solidFill>
-        <a:latin typeface="+mn-lt"/>
-        <a:ea typeface="+mn-ea"/>
-        <a:cs typeface="+mn-cs"/>
-      </a:defRPr>
-    </a:lvl3pPr>
-    <a:lvl4pPr xmlns:a="http://schemas.openxmlformats.org/drawingml/2006/main" marL="1371600" indent="0" algn="l" defTabSz="914400">
-      <a:defRPr sz="1800" kern="1200">
-        <a:solidFill>
-          <a:schemeClr val="tx1"/>
-        </a:solidFill>
-        <a:latin typeface="+mn-lt"/>
-        <a:ea typeface="+mn-ea"/>
-        <a:cs typeface="+mn-cs"/>
-      </a:defRPr>
-    </a:lvl4pPr>
-    <a:lvl5pPr xmlns:a="http://schemas.openxmlformats.org/drawingml/2006/main" marL="1828800" indent="0" algn="l" defTabSz="914400">
-      <a:defRPr sz="1800" kern="1200">
-        <a:solidFill>
-          <a:schemeClr val="tx1"/>
-        </a:solidFill>
-        <a:latin typeface="+mn-lt"/>
-        <a:ea typeface="+mn-ea"/>
-        <a:cs typeface="+mn-cs"/>
-      </a:defRPr>
-    </a:lvl5pPr>
-    <a:lvl6pPr xmlns:a="http://schemas.openxmlformats.org/drawingml/2006/main" marL="2286000" indent="0" algn="l" defTabSz="914400">
-      <a:defRPr sz="1800" kern="1200">
-        <a:solidFill>
-          <a:schemeClr val="tx1"/>
-        </a:solidFill>
-        <a:latin typeface="+mn-lt"/>
-        <a:ea typeface="+mn-ea"/>
-        <a:cs typeface="+mn-cs"/>
-      </a:defRPr>
-    </a:lvl6pPr>
-    <a:lvl7pPr xmlns:a="http://schemas.openxmlformats.org/drawingml/2006/main" marL="2743200" indent="0" algn="l" defTabSz="914400">
-      <a:defRPr sz="1800" kern="1200">
-        <a:solidFill>
-          <a:schemeClr val="tx1"/>
-        </a:solidFill>
-        <a:latin typeface="+mn-lt"/>
-        <a:ea typeface="+mn-ea"/>
-        <a:cs typeface="+mn-cs"/>
-      </a:defRPr>
-    </a:lvl7pPr>
-    <a:lvl8pPr xmlns:a="http://schemas.openxmlformats.org/drawingml/2006/main" marL="3200400" indent="0" algn="l" defTabSz="914400">
-      <a:defRPr sz="1800" kern="1200">
-        <a:solidFill>
-          <a:schemeClr val="tx1"/>
-        </a:solidFill>
-        <a:latin typeface="+mn-lt"/>
-        <a:ea typeface="+mn-ea"/>
-        <a:cs typeface="+mn-cs"/>
-      </a:defRPr>
-    </a:lvl8pPr>
-    <a:lvl9pPr xmlns:a="http://schemas.openxmlformats.org/drawingml/2006/main" marL="3657600" indent="0" algn="l" defTabSz="914400">
-      <a:defRPr sz="1800" kern="1200">
-        <a:solidFill>
-          <a:schemeClr val="tx1"/>
-        </a:solidFill>
-        <a:latin typeface="+mn-lt"/>
-        <a:ea typeface="+mn-ea"/>
-        <a:cs typeface="+mn-cs"/>
-      </a:defRPr>
-    </a:lvl9pPr>
-  </p:defaultTextStyle>
 </p:presentation>
 </file>
 
@@ -668,7 +573,7 @@
   </p:cSld>
   <p:clrMap bg1="lt1" tx1="dk1" bg2="lt2" tx2="dk2" accent1="accent1" accent2="accent2" accent3="accent3" accent4="accent4" accent5="accent5" accent6="accent6" hlink="hlink" folHlink="folHlink"/>
   <p:sldLayoutIdLst>
-    <p:sldLayoutId xmlns:r="http://schemas.openxmlformats.org/officeDocument/2006/relationships" id="2147483649" r:id="Re9920e31403c43b0"/>
+    <p:sldLayoutId xmlns:r="http://schemas.openxmlformats.org/officeDocument/2006/relationships" id="2147483649" r:id="R05f7237615854fab"/>
   </p:sldLayoutIdLst>
   <p:txStyles>
     <p:titleStyle>
@@ -1247,6 +1152,7 @@
           <a:lstStyle xmlns:a="http://schemas.openxmlformats.org/drawingml/2006/main"/>
           <a:p xmlns:a="http://schemas.openxmlformats.org/drawingml/2006/main">
             <a:pPr algn="l">
+              <a:buNone/>
               <a:defRPr sz="3150" b="1">
                 <a:solidFill>
                   <a:srgbClr val="312D2A"/>
@@ -1259,7 +1165,7 @@
                   <a:srgbClr val="312D2A"/>
                 </a:solidFill>
               </a:rPr>
-              <a:t>Arquitetura HA - Spring Boot + OCI Streaming</a:t>
+              <a:t>HA Architecture - Spring Boot + OCI Streaming</a:t>
             </a:r>
           </a:p>
         </p:txBody>
@@ -1297,6 +1203,7 @@
           <a:lstStyle xmlns:a="http://schemas.openxmlformats.org/drawingml/2006/main"/>
           <a:p xmlns:a="http://schemas.openxmlformats.org/drawingml/2006/main">
             <a:pPr algn="l">
+              <a:buNone/>
               <a:defRPr sz="1350" b="0">
                 <a:solidFill>
                   <a:srgbClr val="6F6A65"/>
@@ -1309,7 +1216,7 @@
                   <a:srgbClr val="6F6A65"/>
                 </a:solidFill>
               </a:rPr>
-              <a:t>Producer e consumer Kafka API com failover automatico entre regioes OCI</a:t>
+              <a:t>Kafka API producer and consumer with automatic failover across OCI regions</a:t>
             </a:r>
           </a:p>
         </p:txBody>
@@ -1347,6 +1254,7 @@
           <a:lstStyle xmlns:a="http://schemas.openxmlformats.org/drawingml/2006/main"/>
           <a:p xmlns:a="http://schemas.openxmlformats.org/drawingml/2006/main">
             <a:pPr algn="r">
+              <a:buNone/>
               <a:defRPr sz="900" b="0">
                 <a:solidFill>
                   <a:srgbClr val="6F6A65"/>
@@ -1359,7 +1267,7 @@
                   <a:srgbClr val="6F6A65"/>
                 </a:solidFill>
               </a:rPr>
-              <a:t>Fonte visual: OCI_Icons.pptx / OCI Architecture Diagram Toolkit</a:t>
+              <a:t>Visual source: OCI_Icons.pptx / OCI Architecture Diagram Toolkit</a:t>
             </a:r>
           </a:p>
         </p:txBody>
@@ -1432,6 +1340,7 @@
           <a:lstStyle xmlns:a="http://schemas.openxmlformats.org/drawingml/2006/main"/>
           <a:p xmlns:a="http://schemas.openxmlformats.org/drawingml/2006/main">
             <a:pPr algn="l">
+              <a:buNone/>
               <a:defRPr sz="1575" b="1">
                 <a:solidFill>
                   <a:srgbClr val="312D2A"/>
@@ -1444,7 +1353,7 @@
                   <a:srgbClr val="312D2A"/>
                 </a:solidFill>
               </a:rPr>
-              <a:t>Execucao da demo</a:t>
+              <a:t>Demo runtime</a:t>
             </a:r>
           </a:p>
         </p:txBody>
@@ -1482,6 +1391,7 @@
           <a:lstStyle xmlns:a="http://schemas.openxmlformats.org/drawingml/2006/main"/>
           <a:p xmlns:a="http://schemas.openxmlformats.org/drawingml/2006/main">
             <a:pPr algn="l">
+              <a:buNone/>
               <a:defRPr sz="1050" b="0">
                 <a:solidFill>
                   <a:srgbClr val="6F6A65"/>
@@ -1494,7 +1404,7 @@
                   <a:srgbClr val="6F6A65"/>
                 </a:solidFill>
               </a:rPr>
-              <a:t>Console/Eclipse + app Spring Boot</a:t>
+              <a:t>Console/Eclipse + Spring Boot app</a:t>
             </a:r>
           </a:p>
         </p:txBody>
@@ -1567,6 +1477,7 @@
           <a:lstStyle xmlns:a="http://schemas.openxmlformats.org/drawingml/2006/main"/>
           <a:p xmlns:a="http://schemas.openxmlformats.org/drawingml/2006/main">
             <a:pPr algn="l">
+              <a:buNone/>
               <a:defRPr sz="1575" b="1">
                 <a:solidFill>
                   <a:srgbClr val="17404A"/>
@@ -1579,7 +1490,7 @@
                   <a:srgbClr val="17404A"/>
                 </a:solidFill>
               </a:rPr>
-              <a:t>Regiao primaria</a:t>
+              <a:t>Primary region</a:t>
             </a:r>
           </a:p>
         </p:txBody>
@@ -1617,6 +1528,7 @@
           <a:lstStyle xmlns:a="http://schemas.openxmlformats.org/drawingml/2006/main"/>
           <a:p xmlns:a="http://schemas.openxmlformats.org/drawingml/2006/main">
             <a:pPr algn="l">
+              <a:buNone/>
               <a:defRPr sz="1050" b="0">
                 <a:solidFill>
                   <a:srgbClr val="6F6A65"/>
@@ -1629,7 +1541,7 @@
                   <a:srgbClr val="6F6A65"/>
                 </a:solidFill>
               </a:rPr>
-              <a:t>OCI Streaming ativo</a:t>
+              <a:t>Active OCI Streaming</a:t>
             </a:r>
           </a:p>
         </p:txBody>
@@ -1702,6 +1614,7 @@
           <a:lstStyle xmlns:a="http://schemas.openxmlformats.org/drawingml/2006/main"/>
           <a:p xmlns:a="http://schemas.openxmlformats.org/drawingml/2006/main">
             <a:pPr algn="l">
+              <a:buNone/>
               <a:defRPr sz="1575" b="1">
                 <a:solidFill>
                   <a:srgbClr val="C74634"/>
@@ -1714,7 +1627,7 @@
                   <a:srgbClr val="C74634"/>
                 </a:solidFill>
               </a:rPr>
-              <a:t>Regiao secundaria</a:t>
+              <a:t>Secondary region</a:t>
             </a:r>
           </a:p>
         </p:txBody>
@@ -1752,6 +1665,7 @@
           <a:lstStyle xmlns:a="http://schemas.openxmlformats.org/drawingml/2006/main"/>
           <a:p xmlns:a="http://schemas.openxmlformats.org/drawingml/2006/main">
             <a:pPr algn="l">
+              <a:buNone/>
               <a:defRPr sz="1050" b="0">
                 <a:solidFill>
                   <a:srgbClr val="6F6A65"/>
@@ -1764,7 +1678,7 @@
                   <a:srgbClr val="6F6A65"/>
                 </a:solidFill>
               </a:rPr>
-              <a:t>Criada ou reutilizada no failover</a:t>
+              <a:t>Created or reused during failover</a:t>
             </a:r>
           </a:p>
         </p:txBody>
@@ -1845,14 +1759,14 @@
       </p:sp>
       <p:pic>
         <p:nvPicPr>
-          <p:cNvPr id="102" name=""/>
+          <p:cNvPr id="290" name=""/>
           <p:cNvPicPr>
             <a:picLocks xmlns:a="http://schemas.openxmlformats.org/drawingml/2006/main" noChangeAspect="1"/>
           </p:cNvPicPr>
           <p:nvPr/>
         </p:nvPicPr>
         <p:blipFill>
-          <a:blip xmlns:r="http://schemas.openxmlformats.org/officeDocument/2006/relationships" xmlns:a="http://schemas.openxmlformats.org/drawingml/2006/main" r:embed="Rd4749321cd054a32"/>
+          <a:blip xmlns:r="http://schemas.openxmlformats.org/officeDocument/2006/relationships" xmlns:a="http://schemas.openxmlformats.org/drawingml/2006/main" r:embed="R2db92613f3a04c67"/>
           <a:stretch xmlns:a="http://schemas.openxmlformats.org/drawingml/2006/main"/>
         </p:blipFill>
         <p:spPr>
@@ -1898,6 +1812,7 @@
           <a:lstStyle xmlns:a="http://schemas.openxmlformats.org/drawingml/2006/main"/>
           <a:p xmlns:a="http://schemas.openxmlformats.org/drawingml/2006/main">
             <a:pPr algn="l">
+              <a:buNone/>
               <a:defRPr sz="1350" b="1">
                 <a:solidFill>
                   <a:srgbClr val="312D2A"/>
@@ -1910,7 +1825,7 @@
                   <a:srgbClr val="312D2A"/>
                 </a:solidFill>
               </a:rPr>
-              <a:t>Operador</a:t>
+              <a:t>Operator</a:t>
             </a:r>
           </a:p>
         </p:txBody>
@@ -1948,6 +1863,7 @@
           <a:lstStyle xmlns:a="http://schemas.openxmlformats.org/drawingml/2006/main"/>
           <a:p xmlns:a="http://schemas.openxmlformats.org/drawingml/2006/main">
             <a:pPr algn="l">
+              <a:buNone/>
               <a:defRPr sz="975" b="0">
                 <a:solidFill>
                   <a:srgbClr val="6F6A65"/>
@@ -1960,7 +1876,7 @@
                   <a:srgbClr val="6F6A65"/>
                 </a:solidFill>
               </a:rPr>
-              <a:t>Define a quantidade de mensagens pelo console do Eclipse.</a:t>
+              <a:t>Sets the message count in the Eclipse console.</a:t>
             </a:r>
           </a:p>
         </p:txBody>
@@ -2041,14 +1957,14 @@
       </p:sp>
       <p:pic>
         <p:nvPicPr>
-          <p:cNvPr id="107" name=""/>
+          <p:cNvPr id="295" name=""/>
           <p:cNvPicPr>
             <a:picLocks xmlns:a="http://schemas.openxmlformats.org/drawingml/2006/main" noChangeAspect="1"/>
           </p:cNvPicPr>
           <p:nvPr/>
         </p:nvPicPr>
         <p:blipFill>
-          <a:blip xmlns:r="http://schemas.openxmlformats.org/officeDocument/2006/relationships" xmlns:a="http://schemas.openxmlformats.org/drawingml/2006/main" r:embed="Rba54e689d56845b4"/>
+          <a:blip xmlns:r="http://schemas.openxmlformats.org/officeDocument/2006/relationships" xmlns:a="http://schemas.openxmlformats.org/drawingml/2006/main" r:embed="R0d6b67756ae8454b"/>
           <a:stretch xmlns:a="http://schemas.openxmlformats.org/drawingml/2006/main"/>
         </p:blipFill>
         <p:spPr>
@@ -2094,6 +2010,7 @@
           <a:lstStyle xmlns:a="http://schemas.openxmlformats.org/drawingml/2006/main"/>
           <a:p xmlns:a="http://schemas.openxmlformats.org/drawingml/2006/main">
             <a:pPr algn="l">
+              <a:buNone/>
               <a:defRPr sz="1350" b="1">
                 <a:solidFill>
                   <a:srgbClr val="312D2A"/>
@@ -2144,6 +2061,7 @@
           <a:lstStyle xmlns:a="http://schemas.openxmlformats.org/drawingml/2006/main"/>
           <a:p xmlns:a="http://schemas.openxmlformats.org/drawingml/2006/main">
             <a:pPr algn="l">
+              <a:buNone/>
               <a:defRPr sz="975" b="0">
                 <a:solidFill>
                   <a:srgbClr val="6F6A65"/>
@@ -2156,7 +2074,7 @@
                   <a:srgbClr val="6F6A65"/>
                 </a:solidFill>
               </a:rPr>
-              <a:t>Producer, consumer batch, retry/DLQ, idempotencia e failover.</a:t>
+              <a:t>Producer, batch consumer, retry/DLQ, idempotency, and failover.</a:t>
             </a:r>
           </a:p>
         </p:txBody>
@@ -2237,14 +2155,14 @@
       </p:sp>
       <p:pic>
         <p:nvPicPr>
-          <p:cNvPr id="112" name=""/>
+          <p:cNvPr id="300" name=""/>
           <p:cNvPicPr>
             <a:picLocks xmlns:a="http://schemas.openxmlformats.org/drawingml/2006/main" noChangeAspect="1"/>
           </p:cNvPicPr>
           <p:nvPr/>
         </p:nvPicPr>
         <p:blipFill>
-          <a:blip xmlns:r="http://schemas.openxmlformats.org/officeDocument/2006/relationships" xmlns:a="http://schemas.openxmlformats.org/drawingml/2006/main" r:embed="Rb9198e3db0f14b10"/>
+          <a:blip xmlns:r="http://schemas.openxmlformats.org/officeDocument/2006/relationships" xmlns:a="http://schemas.openxmlformats.org/drawingml/2006/main" r:embed="R87924889c2844478"/>
           <a:stretch xmlns:a="http://schemas.openxmlformats.org/drawingml/2006/main"/>
         </p:blipFill>
         <p:spPr>
@@ -2290,6 +2208,7 @@
           <a:lstStyle xmlns:a="http://schemas.openxmlformats.org/drawingml/2006/main"/>
           <a:p xmlns:a="http://schemas.openxmlformats.org/drawingml/2006/main">
             <a:pPr algn="l">
+              <a:buNone/>
               <a:defRPr sz="1350" b="1">
                 <a:solidFill>
                   <a:srgbClr val="312D2A"/>
@@ -2340,6 +2259,7 @@
           <a:lstStyle xmlns:a="http://schemas.openxmlformats.org/drawingml/2006/main"/>
           <a:p xmlns:a="http://schemas.openxmlformats.org/drawingml/2006/main">
             <a:pPr algn="l">
+              <a:buNone/>
               <a:defRPr sz="975" b="0">
                 <a:solidFill>
                   <a:srgbClr val="6F6A65"/>
@@ -2352,7 +2272,7 @@
                   <a:srgbClr val="6F6A65"/>
                 </a:solidFill>
               </a:rPr>
-              <a:t>Controle idempotente dos eventos ja processados.</a:t>
+              <a:t>Idempotent control of already processed events.</a:t>
             </a:r>
           </a:p>
         </p:txBody>
@@ -2433,14 +2353,14 @@
       </p:sp>
       <p:pic>
         <p:nvPicPr>
-          <p:cNvPr id="117" name=""/>
+          <p:cNvPr id="305" name=""/>
           <p:cNvPicPr>
             <a:picLocks xmlns:a="http://schemas.openxmlformats.org/drawingml/2006/main" noChangeAspect="1"/>
           </p:cNvPicPr>
           <p:nvPr/>
         </p:nvPicPr>
         <p:blipFill>
-          <a:blip xmlns:r="http://schemas.openxmlformats.org/officeDocument/2006/relationships" xmlns:a="http://schemas.openxmlformats.org/drawingml/2006/main" r:embed="Rffcbf4f42155416a"/>
+          <a:blip xmlns:r="http://schemas.openxmlformats.org/officeDocument/2006/relationships" xmlns:a="http://schemas.openxmlformats.org/drawingml/2006/main" r:embed="R0be28bac086b44b6"/>
           <a:stretch xmlns:a="http://schemas.openxmlformats.org/drawingml/2006/main"/>
         </p:blipFill>
         <p:spPr>
@@ -2486,6 +2406,7 @@
           <a:lstStyle xmlns:a="http://schemas.openxmlformats.org/drawingml/2006/main"/>
           <a:p xmlns:a="http://schemas.openxmlformats.org/drawingml/2006/main">
             <a:pPr algn="l">
+              <a:buNone/>
               <a:defRPr sz="1350" b="1">
                 <a:solidFill>
                   <a:srgbClr val="312D2A"/>
@@ -2536,6 +2457,7 @@
           <a:lstStyle xmlns:a="http://schemas.openxmlformats.org/drawingml/2006/main"/>
           <a:p xmlns:a="http://schemas.openxmlformats.org/drawingml/2006/main">
             <a:pPr algn="l">
+              <a:buNone/>
               <a:defRPr sz="975" b="0">
                 <a:solidFill>
                   <a:srgbClr val="6F6A65"/>
@@ -2548,7 +2470,7 @@
                   <a:srgbClr val="6F6A65"/>
                 </a:solidFill>
               </a:rPr>
-              <a:t>Bootstrap secundario persistido apos failover.</a:t>
+              <a:t>Secondary bootstrap persisted after failover.</a:t>
             </a:r>
           </a:p>
         </p:txBody>
@@ -2629,14 +2551,14 @@
       </p:sp>
       <p:pic>
         <p:nvPicPr>
-          <p:cNvPr id="122" name=""/>
+          <p:cNvPr id="310" name=""/>
           <p:cNvPicPr>
             <a:picLocks xmlns:a="http://schemas.openxmlformats.org/drawingml/2006/main" noChangeAspect="1"/>
           </p:cNvPicPr>
           <p:nvPr/>
         </p:nvPicPr>
         <p:blipFill>
-          <a:blip xmlns:r="http://schemas.openxmlformats.org/officeDocument/2006/relationships" xmlns:a="http://schemas.openxmlformats.org/drawingml/2006/main" r:embed="Rf2f25a76aaeb45d8"/>
+          <a:blip xmlns:r="http://schemas.openxmlformats.org/officeDocument/2006/relationships" xmlns:a="http://schemas.openxmlformats.org/drawingml/2006/main" r:embed="R219561901ea04488"/>
           <a:stretch xmlns:a="http://schemas.openxmlformats.org/drawingml/2006/main"/>
         </p:blipFill>
         <p:spPr>
@@ -2682,6 +2604,7 @@
           <a:lstStyle xmlns:a="http://schemas.openxmlformats.org/drawingml/2006/main"/>
           <a:p xmlns:a="http://schemas.openxmlformats.org/drawingml/2006/main">
             <a:pPr algn="l">
+              <a:buNone/>
               <a:defRPr sz="1350" b="1">
                 <a:solidFill>
                   <a:srgbClr val="312D2A"/>
@@ -2694,7 +2617,7 @@
                   <a:srgbClr val="312D2A"/>
                 </a:solidFill>
               </a:rPr>
-              <a:t>VCN / acesso Kafka</a:t>
+              <a:t>VCN / Kafka access</a:t>
             </a:r>
           </a:p>
         </p:txBody>
@@ -2732,6 +2655,7 @@
           <a:lstStyle xmlns:a="http://schemas.openxmlformats.org/drawingml/2006/main"/>
           <a:p xmlns:a="http://schemas.openxmlformats.org/drawingml/2006/main">
             <a:pPr algn="l">
+              <a:buNone/>
               <a:defRPr sz="975" b="0">
                 <a:solidFill>
                   <a:srgbClr val="6F6A65"/>
@@ -2744,7 +2668,7 @@
                   <a:srgbClr val="6F6A65"/>
                 </a:solidFill>
               </a:rPr>
-              <a:t>Conectividade para o endpoint Kafka compativel.</a:t>
+              <a:t>Connectivity to the Kafka-compatible endpoint.</a:t>
             </a:r>
           </a:p>
         </p:txBody>
@@ -2825,14 +2749,14 @@
       </p:sp>
       <p:pic>
         <p:nvPicPr>
-          <p:cNvPr id="127" name=""/>
+          <p:cNvPr id="315" name=""/>
           <p:cNvPicPr>
             <a:picLocks xmlns:a="http://schemas.openxmlformats.org/drawingml/2006/main" noChangeAspect="1"/>
           </p:cNvPicPr>
           <p:nvPr/>
         </p:nvPicPr>
         <p:blipFill>
-          <a:blip xmlns:r="http://schemas.openxmlformats.org/officeDocument/2006/relationships" xmlns:a="http://schemas.openxmlformats.org/drawingml/2006/main" r:embed="R3159f66c48104c6f"/>
+          <a:blip xmlns:r="http://schemas.openxmlformats.org/officeDocument/2006/relationships" xmlns:a="http://schemas.openxmlformats.org/drawingml/2006/main" r:embed="R2e7176f450ad48f5"/>
           <a:stretch xmlns:a="http://schemas.openxmlformats.org/drawingml/2006/main"/>
         </p:blipFill>
         <p:spPr>
@@ -2878,6 +2802,7 @@
           <a:lstStyle xmlns:a="http://schemas.openxmlformats.org/drawingml/2006/main"/>
           <a:p xmlns:a="http://schemas.openxmlformats.org/drawingml/2006/main">
             <a:pPr algn="l">
+              <a:buNone/>
               <a:defRPr sz="1350" b="1">
                 <a:solidFill>
                   <a:srgbClr val="312D2A"/>
@@ -2928,6 +2853,7 @@
           <a:lstStyle xmlns:a="http://schemas.openxmlformats.org/drawingml/2006/main"/>
           <a:p xmlns:a="http://schemas.openxmlformats.org/drawingml/2006/main">
             <a:pPr algn="l">
+              <a:buNone/>
               <a:defRPr sz="975" b="0">
                 <a:solidFill>
                   <a:srgbClr val="6F6A65"/>
@@ -2940,7 +2866,7 @@
                   <a:srgbClr val="6F6A65"/>
                 </a:solidFill>
               </a:rPr>
-              <a:t>Stream principal com partition key consistente por orderId.</a:t>
+              <a:t>Primary stream with a consistent partition key by orderId.</a:t>
             </a:r>
           </a:p>
         </p:txBody>
@@ -3021,14 +2947,14 @@
       </p:sp>
       <p:pic>
         <p:nvPicPr>
-          <p:cNvPr id="132" name=""/>
+          <p:cNvPr id="320" name=""/>
           <p:cNvPicPr>
             <a:picLocks xmlns:a="http://schemas.openxmlformats.org/drawingml/2006/main" noChangeAspect="1"/>
           </p:cNvPicPr>
           <p:nvPr/>
         </p:nvPicPr>
         <p:blipFill>
-          <a:blip xmlns:r="http://schemas.openxmlformats.org/officeDocument/2006/relationships" xmlns:a="http://schemas.openxmlformats.org/drawingml/2006/main" r:embed="R5984aab8800741f1"/>
+          <a:blip xmlns:r="http://schemas.openxmlformats.org/officeDocument/2006/relationships" xmlns:a="http://schemas.openxmlformats.org/drawingml/2006/main" r:embed="Rcc01dbcd65ae4afe"/>
           <a:stretch xmlns:a="http://schemas.openxmlformats.org/drawingml/2006/main"/>
         </p:blipFill>
         <p:spPr>
@@ -3074,6 +3000,7 @@
           <a:lstStyle xmlns:a="http://schemas.openxmlformats.org/drawingml/2006/main"/>
           <a:p xmlns:a="http://schemas.openxmlformats.org/drawingml/2006/main">
             <a:pPr algn="l">
+              <a:buNone/>
               <a:defRPr sz="1350" b="1">
                 <a:solidFill>
                   <a:srgbClr val="312D2A"/>
@@ -3124,6 +3051,7 @@
           <a:lstStyle xmlns:a="http://schemas.openxmlformats.org/drawingml/2006/main"/>
           <a:p xmlns:a="http://schemas.openxmlformats.org/drawingml/2006/main">
             <a:pPr algn="l">
+              <a:buNone/>
               <a:defRPr sz="975" b="0">
                 <a:solidFill>
                   <a:srgbClr val="6F6A65"/>
@@ -3136,7 +3064,7 @@
                   <a:srgbClr val="6F6A65"/>
                 </a:solidFill>
               </a:rPr>
-              <a:t>Falhas permanentes depois das tentativas configuradas.</a:t>
+              <a:t>Permanent failures after configured attempts.</a:t>
             </a:r>
           </a:p>
         </p:txBody>
@@ -3217,14 +3145,14 @@
       </p:sp>
       <p:pic>
         <p:nvPicPr>
-          <p:cNvPr id="137" name=""/>
+          <p:cNvPr id="325" name=""/>
           <p:cNvPicPr>
             <a:picLocks xmlns:a="http://schemas.openxmlformats.org/drawingml/2006/main" noChangeAspect="1"/>
           </p:cNvPicPr>
           <p:nvPr/>
         </p:nvPicPr>
         <p:blipFill>
-          <a:blip xmlns:r="http://schemas.openxmlformats.org/officeDocument/2006/relationships" xmlns:a="http://schemas.openxmlformats.org/drawingml/2006/main" r:embed="R9c3baf14d0c6472c"/>
+          <a:blip xmlns:r="http://schemas.openxmlformats.org/officeDocument/2006/relationships" xmlns:a="http://schemas.openxmlformats.org/drawingml/2006/main" r:embed="R7a2a0c4ac5d441d2"/>
           <a:stretch xmlns:a="http://schemas.openxmlformats.org/drawingml/2006/main"/>
         </p:blipFill>
         <p:spPr>
@@ -3270,6 +3198,7 @@
           <a:lstStyle xmlns:a="http://schemas.openxmlformats.org/drawingml/2006/main"/>
           <a:p xmlns:a="http://schemas.openxmlformats.org/drawingml/2006/main">
             <a:pPr algn="l">
+              <a:buNone/>
               <a:defRPr sz="1350" b="1">
                 <a:solidFill>
                   <a:srgbClr val="312D2A"/>
@@ -3320,6 +3249,7 @@
           <a:lstStyle xmlns:a="http://schemas.openxmlformats.org/drawingml/2006/main"/>
           <a:p xmlns:a="http://schemas.openxmlformats.org/drawingml/2006/main">
             <a:pPr algn="l">
+              <a:buNone/>
               <a:defRPr sz="975" b="0">
                 <a:solidFill>
                   <a:srgbClr val="6F6A65"/>
@@ -3332,7 +3262,7 @@
                   <a:srgbClr val="6F6A65"/>
                 </a:solidFill>
               </a:rPr>
-              <a:t>AdminClient, /actuator/metrics e /actuator/prometheus.</a:t>
+              <a:t>AdminClient, /actuator/metrics and /actuator/prometheus.</a:t>
             </a:r>
           </a:p>
         </p:txBody>
@@ -3413,14 +3343,14 @@
       </p:sp>
       <p:pic>
         <p:nvPicPr>
-          <p:cNvPr id="142" name=""/>
+          <p:cNvPr id="330" name=""/>
           <p:cNvPicPr>
             <a:picLocks xmlns:a="http://schemas.openxmlformats.org/drawingml/2006/main" noChangeAspect="1"/>
           </p:cNvPicPr>
           <p:nvPr/>
         </p:nvPicPr>
         <p:blipFill>
-          <a:blip xmlns:r="http://schemas.openxmlformats.org/officeDocument/2006/relationships" xmlns:a="http://schemas.openxmlformats.org/drawingml/2006/main" r:embed="Red48bb98cdf74ae0"/>
+          <a:blip xmlns:r="http://schemas.openxmlformats.org/officeDocument/2006/relationships" xmlns:a="http://schemas.openxmlformats.org/drawingml/2006/main" r:embed="R8acd6f8e0da04f65"/>
           <a:stretch xmlns:a="http://schemas.openxmlformats.org/drawingml/2006/main"/>
         </p:blipFill>
         <p:spPr>
@@ -3466,6 +3396,7 @@
           <a:lstStyle xmlns:a="http://schemas.openxmlformats.org/drawingml/2006/main"/>
           <a:p xmlns:a="http://schemas.openxmlformats.org/drawingml/2006/main">
             <a:pPr algn="l">
+              <a:buNone/>
               <a:defRPr sz="1350" b="1">
                 <a:solidFill>
                   <a:srgbClr val="312D2A"/>
@@ -3516,6 +3447,7 @@
           <a:lstStyle xmlns:a="http://schemas.openxmlformats.org/drawingml/2006/main"/>
           <a:p xmlns:a="http://schemas.openxmlformats.org/drawingml/2006/main">
             <a:pPr algn="l">
+              <a:buNone/>
               <a:defRPr sz="975" b="0">
                 <a:solidFill>
                   <a:srgbClr val="6F6A65"/>
@@ -3528,7 +3460,7 @@
                   <a:srgbClr val="6F6A65"/>
                 </a:solidFill>
               </a:rPr>
-              <a:t>Detecta timeout/500/429 e aciona OCI SDK.</a:t>
+              <a:t>Detects timeout/500/429 and invokes the OCI SDK.</a:t>
             </a:r>
           </a:p>
         </p:txBody>
@@ -3609,14 +3541,14 @@
       </p:sp>
       <p:pic>
         <p:nvPicPr>
-          <p:cNvPr id="147" name=""/>
+          <p:cNvPr id="335" name=""/>
           <p:cNvPicPr>
             <a:picLocks xmlns:a="http://schemas.openxmlformats.org/drawingml/2006/main" noChangeAspect="1"/>
           </p:cNvPicPr>
           <p:nvPr/>
         </p:nvPicPr>
         <p:blipFill>
-          <a:blip xmlns:r="http://schemas.openxmlformats.org/officeDocument/2006/relationships" xmlns:a="http://schemas.openxmlformats.org/drawingml/2006/main" r:embed="Rab7883a36190417b"/>
+          <a:blip xmlns:r="http://schemas.openxmlformats.org/officeDocument/2006/relationships" xmlns:a="http://schemas.openxmlformats.org/drawingml/2006/main" r:embed="R136486c714a440d8"/>
           <a:stretch xmlns:a="http://schemas.openxmlformats.org/drawingml/2006/main"/>
         </p:blipFill>
         <p:spPr>
@@ -3662,6 +3594,7 @@
           <a:lstStyle xmlns:a="http://schemas.openxmlformats.org/drawingml/2006/main"/>
           <a:p xmlns:a="http://schemas.openxmlformats.org/drawingml/2006/main">
             <a:pPr algn="l">
+              <a:buNone/>
               <a:defRPr sz="1350" b="1">
                 <a:solidFill>
                   <a:srgbClr val="312D2A"/>
@@ -3674,7 +3607,7 @@
                   <a:srgbClr val="312D2A"/>
                 </a:solidFill>
               </a:rPr>
-              <a:t>OCI Streaming secundario</a:t>
+              <a:t>Secondary OCI Streaming</a:t>
             </a:r>
           </a:p>
         </p:txBody>
@@ -3712,6 +3645,7 @@
           <a:lstStyle xmlns:a="http://schemas.openxmlformats.org/drawingml/2006/main"/>
           <a:p xmlns:a="http://schemas.openxmlformats.org/drawingml/2006/main">
             <a:pPr algn="l">
+              <a:buNone/>
               <a:defRPr sz="975" b="0">
                 <a:solidFill>
                   <a:srgbClr val="6F6A65"/>
@@ -3724,7 +3658,7 @@
                   <a:srgbClr val="6F6A65"/>
                 </a:solidFill>
               </a:rPr>
-              <a:t>Stream criado ou reutilizado em sa-vinhedo-1.</a:t>
+              <a:t>Stream created or reused in sa-vinhedo-1.</a:t>
             </a:r>
           </a:p>
         </p:txBody>
@@ -3805,14 +3739,14 @@
       </p:sp>
       <p:pic>
         <p:nvPicPr>
-          <p:cNvPr id="152" name=""/>
+          <p:cNvPr id="340" name=""/>
           <p:cNvPicPr>
             <a:picLocks xmlns:a="http://schemas.openxmlformats.org/drawingml/2006/main" noChangeAspect="1"/>
           </p:cNvPicPr>
           <p:nvPr/>
         </p:nvPicPr>
         <p:blipFill>
-          <a:blip xmlns:r="http://schemas.openxmlformats.org/officeDocument/2006/relationships" xmlns:a="http://schemas.openxmlformats.org/drawingml/2006/main" r:embed="R70ceb91116b94842"/>
+          <a:blip xmlns:r="http://schemas.openxmlformats.org/officeDocument/2006/relationships" xmlns:a="http://schemas.openxmlformats.org/drawingml/2006/main" r:embed="R22db217b61f54b6c"/>
           <a:stretch xmlns:a="http://schemas.openxmlformats.org/drawingml/2006/main"/>
         </p:blipFill>
         <p:spPr>
@@ -3858,6 +3792,7 @@
           <a:lstStyle xmlns:a="http://schemas.openxmlformats.org/drawingml/2006/main"/>
           <a:p xmlns:a="http://schemas.openxmlformats.org/drawingml/2006/main">
             <a:pPr algn="l">
+              <a:buNone/>
               <a:defRPr sz="1350" b="1">
                 <a:solidFill>
                   <a:srgbClr val="312D2A"/>
@@ -3870,7 +3805,7 @@
                   <a:srgbClr val="312D2A"/>
                 </a:solidFill>
               </a:rPr>
-              <a:t>DLQ secundaria</a:t>
+              <a:t>Secondary DLQ</a:t>
             </a:r>
           </a:p>
         </p:txBody>
@@ -3908,6 +3843,7 @@
           <a:lstStyle xmlns:a="http://schemas.openxmlformats.org/drawingml/2006/main"/>
           <a:p xmlns:a="http://schemas.openxmlformats.org/drawingml/2006/main">
             <a:pPr algn="l">
+              <a:buNone/>
               <a:defRPr sz="975" b="0">
                 <a:solidFill>
                   <a:srgbClr val="6F6A65"/>
@@ -3920,14 +3856,14 @@
                   <a:srgbClr val="6F6A65"/>
                 </a:solidFill>
               </a:rPr>
-              <a:t>Mantem isolamento das falhas permanentes apos a troca.</a:t>
+              <a:t>Keeps permanent failures isolated after the switch.</a:t>
             </a:r>
           </a:p>
         </p:txBody>
       </p:sp>
       <p:cxnSp>
         <p:nvCxnSpPr>
-          <p:cNvPr id="155" name=""/>
+          <p:cNvPr id="343" name=""/>
           <p:cNvCxnSpPr>
             <a:stCxn xmlns:a="http://schemas.openxmlformats.org/drawingml/2006/main" id="13" idx="2"/>
             <a:endCxn xmlns:a="http://schemas.openxmlformats.org/drawingml/2006/main" id="18" idx="0"/>
@@ -3984,6 +3920,7 @@
           <a:lstStyle xmlns:a="http://schemas.openxmlformats.org/drawingml/2006/main"/>
           <a:p xmlns:a="http://schemas.openxmlformats.org/drawingml/2006/main">
             <a:pPr algn="ctr">
+              <a:buNone/>
               <a:defRPr sz="900" b="1">
                 <a:solidFill>
                   <a:srgbClr val="2C5967"/>
@@ -3996,14 +3933,14 @@
                   <a:srgbClr val="2C5967"/>
                 </a:solidFill>
               </a:rPr>
-              <a:t>executa</a:t>
+              <a:t>runs</a:t>
             </a:r>
           </a:p>
         </p:txBody>
       </p:sp>
       <p:cxnSp>
         <p:nvCxnSpPr>
-          <p:cNvPr id="157" name=""/>
+          <p:cNvPr id="345" name=""/>
           <p:cNvCxnSpPr>
             <a:stCxn xmlns:a="http://schemas.openxmlformats.org/drawingml/2006/main" id="18" idx="3"/>
             <a:endCxn xmlns:a="http://schemas.openxmlformats.org/drawingml/2006/main" id="38" idx="1"/>
@@ -4062,6 +3999,7 @@
           <a:lstStyle xmlns:a="http://schemas.openxmlformats.org/drawingml/2006/main"/>
           <a:p xmlns:a="http://schemas.openxmlformats.org/drawingml/2006/main">
             <a:pPr algn="ctr">
+              <a:buNone/>
               <a:defRPr sz="900" b="1">
                 <a:solidFill>
                   <a:srgbClr val="2C5967"/>
@@ -4081,7 +4019,7 @@
       </p:sp>
       <p:cxnSp>
         <p:nvCxnSpPr>
-          <p:cNvPr id="159" name=""/>
+          <p:cNvPr id="347" name=""/>
           <p:cNvCxnSpPr>
             <a:stCxn xmlns:a="http://schemas.openxmlformats.org/drawingml/2006/main" id="38" idx="1"/>
             <a:endCxn xmlns:a="http://schemas.openxmlformats.org/drawingml/2006/main" id="18" idx="3"/>
@@ -4109,7 +4047,7 @@
       </p:cxnSp>
       <p:cxnSp>
         <p:nvCxnSpPr>
-          <p:cNvPr id="160" name=""/>
+          <p:cNvPr id="348" name=""/>
           <p:cNvCxnSpPr>
             <a:stCxn xmlns:a="http://schemas.openxmlformats.org/drawingml/2006/main" id="18" idx="2"/>
             <a:endCxn xmlns:a="http://schemas.openxmlformats.org/drawingml/2006/main" id="23" idx="0"/>
@@ -4166,6 +4104,7 @@
           <a:lstStyle xmlns:a="http://schemas.openxmlformats.org/drawingml/2006/main"/>
           <a:p xmlns:a="http://schemas.openxmlformats.org/drawingml/2006/main">
             <a:pPr algn="ctr">
+              <a:buNone/>
               <a:defRPr sz="900" b="1">
                 <a:solidFill>
                   <a:srgbClr val="759C6C"/>
@@ -4178,14 +4117,14 @@
                   <a:srgbClr val="759C6C"/>
                 </a:solidFill>
               </a:rPr>
-              <a:t>idempotencia</a:t>
+              <a:t>idempotency</a:t>
             </a:r>
           </a:p>
         </p:txBody>
       </p:sp>
       <p:cxnSp>
         <p:nvCxnSpPr>
-          <p:cNvPr id="162" name=""/>
+          <p:cNvPr id="350" name=""/>
           <p:cNvCxnSpPr>
             <a:stCxn xmlns:a="http://schemas.openxmlformats.org/drawingml/2006/main" id="18" idx="3"/>
             <a:endCxn xmlns:a="http://schemas.openxmlformats.org/drawingml/2006/main" id="43" idx="1"/>
@@ -4213,7 +4152,7 @@
       </p:cxnSp>
       <p:cxnSp>
         <p:nvCxnSpPr>
-          <p:cNvPr id="163" name=""/>
+          <p:cNvPr id="351" name=""/>
           <p:cNvCxnSpPr>
             <a:stCxn xmlns:a="http://schemas.openxmlformats.org/drawingml/2006/main" id="38" idx="2"/>
             <a:endCxn xmlns:a="http://schemas.openxmlformats.org/drawingml/2006/main" id="48" idx="0"/>
@@ -4270,6 +4209,7 @@
           <a:lstStyle xmlns:a="http://schemas.openxmlformats.org/drawingml/2006/main"/>
           <a:p xmlns:a="http://schemas.openxmlformats.org/drawingml/2006/main">
             <a:pPr algn="ctr">
+              <a:buNone/>
               <a:defRPr sz="900" b="1">
                 <a:solidFill>
                   <a:srgbClr val="759C6C"/>
@@ -4289,7 +4229,7 @@
       </p:sp>
       <p:cxnSp>
         <p:nvCxnSpPr>
-          <p:cNvPr id="165" name=""/>
+          <p:cNvPr id="353" name=""/>
           <p:cNvCxnSpPr>
             <a:stCxn xmlns:a="http://schemas.openxmlformats.org/drawingml/2006/main" id="18" idx="3"/>
             <a:endCxn xmlns:a="http://schemas.openxmlformats.org/drawingml/2006/main" id="53" idx="1"/>
@@ -4317,7 +4257,7 @@
       </p:cxnSp>
       <p:cxnSp>
         <p:nvCxnSpPr>
-          <p:cNvPr id="166" name=""/>
+          <p:cNvPr id="354" name=""/>
           <p:cNvCxnSpPr>
             <a:stCxn xmlns:a="http://schemas.openxmlformats.org/drawingml/2006/main" id="53" idx="2"/>
             <a:endCxn xmlns:a="http://schemas.openxmlformats.org/drawingml/2006/main" id="58" idx="0"/>
@@ -4374,6 +4314,7 @@
           <a:lstStyle xmlns:a="http://schemas.openxmlformats.org/drawingml/2006/main"/>
           <a:p xmlns:a="http://schemas.openxmlformats.org/drawingml/2006/main">
             <a:pPr algn="ctr">
+              <a:buNone/>
               <a:defRPr sz="900" b="1">
                 <a:solidFill>
                   <a:srgbClr val="C74634"/>
@@ -4393,7 +4334,7 @@
       </p:sp>
       <p:cxnSp>
         <p:nvCxnSpPr>
-          <p:cNvPr id="168" name=""/>
+          <p:cNvPr id="356" name=""/>
           <p:cNvCxnSpPr>
             <a:stCxn xmlns:a="http://schemas.openxmlformats.org/drawingml/2006/main" id="53" idx="1"/>
             <a:endCxn xmlns:a="http://schemas.openxmlformats.org/drawingml/2006/main" id="28" idx="3"/>
@@ -4421,7 +4362,7 @@
       </p:cxnSp>
       <p:cxnSp>
         <p:nvCxnSpPr>
-          <p:cNvPr id="169" name=""/>
+          <p:cNvPr id="357" name=""/>
           <p:cNvCxnSpPr>
             <a:stCxn xmlns:a="http://schemas.openxmlformats.org/drawingml/2006/main" id="28" idx="3"/>
             <a:endCxn xmlns:a="http://schemas.openxmlformats.org/drawingml/2006/main" id="58" idx="1"/>
@@ -4449,7 +4390,7 @@
       </p:cxnSp>
       <p:cxnSp>
         <p:nvCxnSpPr>
-          <p:cNvPr id="170" name=""/>
+          <p:cNvPr id="358" name=""/>
           <p:cNvCxnSpPr>
             <a:stCxn xmlns:a="http://schemas.openxmlformats.org/drawingml/2006/main" id="58" idx="2"/>
             <a:endCxn xmlns:a="http://schemas.openxmlformats.org/drawingml/2006/main" id="63" idx="0"/>
@@ -4506,6 +4447,7 @@
           <a:lstStyle xmlns:a="http://schemas.openxmlformats.org/drawingml/2006/main"/>
           <a:p xmlns:a="http://schemas.openxmlformats.org/drawingml/2006/main">
             <a:pPr algn="ctr">
+              <a:buNone/>
               <a:defRPr sz="900" b="1">
                 <a:solidFill>
                   <a:srgbClr val="C74634"/>
@@ -4518,7 +4460,7 @@
                   <a:srgbClr val="C74634"/>
                 </a:solidFill>
               </a:rPr>
-              <a:t>falhas</a:t>
+              <a:t>failures</a:t>
             </a:r>
           </a:p>
         </p:txBody>
@@ -4556,6 +4498,7 @@
           <a:lstStyle xmlns:a="http://schemas.openxmlformats.org/drawingml/2006/main"/>
           <a:p xmlns:a="http://schemas.openxmlformats.org/drawingml/2006/main">
             <a:pPr algn="l">
+              <a:buNone/>
               <a:defRPr sz="1200" b="1">
                 <a:solidFill>
                   <a:srgbClr val="312D2A"/>
@@ -4568,7 +4511,7 @@
                   <a:srgbClr val="312D2A"/>
                 </a:solidFill>
               </a:rPr>
-              <a:t>Chaves de leitura</a:t>
+              <a:t>Legend</a:t>
             </a:r>
           </a:p>
         </p:txBody>
@@ -4606,6 +4549,7 @@
           <a:lstStyle xmlns:a="http://schemas.openxmlformats.org/drawingml/2006/main"/>
           <a:p xmlns:a="http://schemas.openxmlformats.org/drawingml/2006/main">
             <a:pPr algn="l">
+              <a:buNone/>
               <a:defRPr sz="1050" b="0">
                 <a:solidFill>
                   <a:srgbClr val="6F6A65"/>
@@ -4618,7 +4562,7 @@
                   <a:srgbClr val="6F6A65"/>
                 </a:solidFill>
               </a:rPr>
-              <a:t>Azul: envio/stream ativo  |  Verde: consumo, idempotencia e lag  |  Laranja: failover regional  |  Vermelho: DLQ</a:t>
+              <a:t>Blue: send/active stream  |  Green: consumption, idempotency, and lag  |  Orange: regional failover  |  Red: DLQ</a:t>
             </a:r>
           </a:p>
         </p:txBody>
@@ -4656,6 +4600,7 @@
           <a:lstStyle xmlns:a="http://schemas.openxmlformats.org/drawingml/2006/main"/>
           <a:p xmlns:a="http://schemas.openxmlformats.org/drawingml/2006/main">
             <a:pPr algn="r">
+              <a:buNone/>
               <a:defRPr sz="1050" b="1">
                 <a:solidFill>
                   <a:srgbClr val="17404A"/>
@@ -4668,7 +4613,7 @@
                   <a:srgbClr val="17404A"/>
                 </a:solidFill>
               </a:rPr>
-              <a:t>Commit manual ocorre somente apos sucesso do batch.</a:t>
+              <a:t>Manual commit occurs only after the batch succeeds.</a:t>
             </a:r>
           </a:p>
         </p:txBody>
@@ -4735,6 +4680,7 @@
           <a:lstStyle xmlns:a="http://schemas.openxmlformats.org/drawingml/2006/main"/>
           <a:p xmlns:a="http://schemas.openxmlformats.org/drawingml/2006/main">
             <a:pPr algn="l">
+              <a:buNone/>
               <a:defRPr sz="3150" b="1">
                 <a:solidFill>
                   <a:srgbClr val="312D2A"/>
@@ -4747,7 +4693,7 @@
                   <a:srgbClr val="312D2A"/>
                 </a:solidFill>
               </a:rPr>
-              <a:t>Fluxo tecnico do failover</a:t>
+              <a:t>Technical failover flow</a:t>
             </a:r>
           </a:p>
         </p:txBody>
@@ -4785,6 +4731,7 @@
           <a:lstStyle xmlns:a="http://schemas.openxmlformats.org/drawingml/2006/main"/>
           <a:p xmlns:a="http://schemas.openxmlformats.org/drawingml/2006/main">
             <a:pPr algn="l">
+              <a:buNone/>
               <a:defRPr sz="1350" b="0">
                 <a:solidFill>
                   <a:srgbClr val="6F6A65"/>
@@ -4797,7 +4744,7 @@
                   <a:srgbClr val="6F6A65"/>
                 </a:solidFill>
               </a:rPr>
-              <a:t>Como a aplicacao troca endpoint, persiste estado e retoma producer/consumer</a:t>
+              <a:t>How the application switches endpoints, persists state, and resumes producer/consumer</a:t>
             </a:r>
           </a:p>
         </p:txBody>
@@ -4835,6 +4782,7 @@
           <a:lstStyle xmlns:a="http://schemas.openxmlformats.org/drawingml/2006/main"/>
           <a:p xmlns:a="http://schemas.openxmlformats.org/drawingml/2006/main">
             <a:pPr algn="r">
+              <a:buNone/>
               <a:defRPr sz="900" b="0">
                 <a:solidFill>
                   <a:srgbClr val="6F6A65"/>
@@ -4847,7 +4795,7 @@
                   <a:srgbClr val="6F6A65"/>
                 </a:solidFill>
               </a:rPr>
-              <a:t>Fonte visual: OCI_Icons.pptx / OCI Architecture Diagram Toolkit</a:t>
+              <a:t>Visual source: OCI_Icons.pptx / OCI Architecture Diagram Toolkit</a:t>
             </a:r>
           </a:p>
         </p:txBody>
@@ -4928,14 +4876,14 @@
       </p:sp>
       <p:pic>
         <p:nvPicPr>
-          <p:cNvPr id="75" name=""/>
+          <p:cNvPr id="223" name=""/>
           <p:cNvPicPr>
             <a:picLocks xmlns:a="http://schemas.openxmlformats.org/drawingml/2006/main" noChangeAspect="1"/>
           </p:cNvPicPr>
           <p:nvPr/>
         </p:nvPicPr>
         <p:blipFill>
-          <a:blip xmlns:r="http://schemas.openxmlformats.org/officeDocument/2006/relationships" xmlns:a="http://schemas.openxmlformats.org/drawingml/2006/main" r:embed="R0c78d303fc7f47ef"/>
+          <a:blip xmlns:r="http://schemas.openxmlformats.org/officeDocument/2006/relationships" xmlns:a="http://schemas.openxmlformats.org/drawingml/2006/main" r:embed="Rb0d83c3d99574d98"/>
           <a:stretch xmlns:a="http://schemas.openxmlformats.org/drawingml/2006/main"/>
         </p:blipFill>
         <p:spPr>
@@ -4981,6 +4929,7 @@
           <a:lstStyle xmlns:a="http://schemas.openxmlformats.org/drawingml/2006/main"/>
           <a:p xmlns:a="http://schemas.openxmlformats.org/drawingml/2006/main">
             <a:pPr algn="l">
+              <a:buNone/>
               <a:defRPr sz="1350" b="1">
                 <a:solidFill>
                   <a:srgbClr val="312D2A"/>
@@ -4993,7 +4942,7 @@
                   <a:srgbClr val="312D2A"/>
                 </a:solidFill>
               </a:rPr>
-              <a:t>Falha detectada</a:t>
+              <a:t>Failure detected</a:t>
             </a:r>
           </a:p>
         </p:txBody>
@@ -5031,6 +4980,7 @@
           <a:lstStyle xmlns:a="http://schemas.openxmlformats.org/drawingml/2006/main"/>
           <a:p xmlns:a="http://schemas.openxmlformats.org/drawingml/2006/main">
             <a:pPr algn="l">
+              <a:buNone/>
               <a:defRPr sz="975" b="0">
                 <a:solidFill>
                   <a:srgbClr val="6F6A65"/>
@@ -5043,7 +4993,7 @@
                   <a:srgbClr val="6F6A65"/>
                 </a:solidFill>
               </a:rPr>
-              <a:t>Producer ou health check identifica timeout, 500, 429 ou desconexao.</a:t>
+              <a:t>Producer or health check detects timeout, 500, 429, or disconnection.</a:t>
             </a:r>
           </a:p>
         </p:txBody>
@@ -5085,6 +5035,7 @@
           <a:lstStyle xmlns:a="http://schemas.openxmlformats.org/drawingml/2006/main"/>
           <a:p xmlns:a="http://schemas.openxmlformats.org/drawingml/2006/main">
             <a:pPr algn="ctr">
+              <a:buNone/>
               <a:defRPr sz="1350" b="1">
                 <a:solidFill>
                   <a:srgbClr val="FFFFFF"/>
@@ -5178,14 +5129,14 @@
       </p:sp>
       <p:pic>
         <p:nvPicPr>
-          <p:cNvPr id="81" name=""/>
+          <p:cNvPr id="229" name=""/>
           <p:cNvPicPr>
             <a:picLocks xmlns:a="http://schemas.openxmlformats.org/drawingml/2006/main" noChangeAspect="1"/>
           </p:cNvPicPr>
           <p:nvPr/>
         </p:nvPicPr>
         <p:blipFill>
-          <a:blip xmlns:r="http://schemas.openxmlformats.org/officeDocument/2006/relationships" xmlns:a="http://schemas.openxmlformats.org/drawingml/2006/main" r:embed="R0dfa0c8b228141f8"/>
+          <a:blip xmlns:r="http://schemas.openxmlformats.org/officeDocument/2006/relationships" xmlns:a="http://schemas.openxmlformats.org/drawingml/2006/main" r:embed="Re35495014120462c"/>
           <a:stretch xmlns:a="http://schemas.openxmlformats.org/drawingml/2006/main"/>
         </p:blipFill>
         <p:spPr>
@@ -5231,6 +5182,7 @@
           <a:lstStyle xmlns:a="http://schemas.openxmlformats.org/drawingml/2006/main"/>
           <a:p xmlns:a="http://schemas.openxmlformats.org/drawingml/2006/main">
             <a:pPr algn="l">
+              <a:buNone/>
               <a:defRPr sz="1350" b="1">
                 <a:solidFill>
                   <a:srgbClr val="312D2A"/>
@@ -5243,7 +5195,7 @@
                   <a:srgbClr val="312D2A"/>
                 </a:solidFill>
               </a:rPr>
-              <a:t>Coord. HA</a:t>
+              <a:t>HA coord.</a:t>
             </a:r>
           </a:p>
         </p:txBody>
@@ -5281,6 +5233,7 @@
           <a:lstStyle xmlns:a="http://schemas.openxmlformats.org/drawingml/2006/main"/>
           <a:p xmlns:a="http://schemas.openxmlformats.org/drawingml/2006/main">
             <a:pPr algn="l">
+              <a:buNone/>
               <a:defRPr sz="975" b="0">
                 <a:solidFill>
                   <a:srgbClr val="6F6A65"/>
@@ -5293,7 +5246,7 @@
                   <a:srgbClr val="6F6A65"/>
                 </a:solidFill>
               </a:rPr>
-              <a:t>Controla uma unica troca ativa por vez.</a:t>
+              <a:t>Controls one active switch at a time.</a:t>
             </a:r>
           </a:p>
         </p:txBody>
@@ -5335,6 +5288,7 @@
           <a:lstStyle xmlns:a="http://schemas.openxmlformats.org/drawingml/2006/main"/>
           <a:p xmlns:a="http://schemas.openxmlformats.org/drawingml/2006/main">
             <a:pPr algn="ctr">
+              <a:buNone/>
               <a:defRPr sz="1350" b="1">
                 <a:solidFill>
                   <a:srgbClr val="FFFFFF"/>
@@ -5428,14 +5382,14 @@
       </p:sp>
       <p:pic>
         <p:nvPicPr>
-          <p:cNvPr id="87" name=""/>
+          <p:cNvPr id="235" name=""/>
           <p:cNvPicPr>
             <a:picLocks xmlns:a="http://schemas.openxmlformats.org/drawingml/2006/main" noChangeAspect="1"/>
           </p:cNvPicPr>
           <p:nvPr/>
         </p:nvPicPr>
         <p:blipFill>
-          <a:blip xmlns:r="http://schemas.openxmlformats.org/officeDocument/2006/relationships" xmlns:a="http://schemas.openxmlformats.org/drawingml/2006/main" r:embed="R762e76c3e1bf46ee"/>
+          <a:blip xmlns:r="http://schemas.openxmlformats.org/officeDocument/2006/relationships" xmlns:a="http://schemas.openxmlformats.org/drawingml/2006/main" r:embed="R89fa139168f64dd2"/>
           <a:stretch xmlns:a="http://schemas.openxmlformats.org/drawingml/2006/main"/>
         </p:blipFill>
         <p:spPr>
@@ -5481,6 +5435,7 @@
           <a:lstStyle xmlns:a="http://schemas.openxmlformats.org/drawingml/2006/main"/>
           <a:p xmlns:a="http://schemas.openxmlformats.org/drawingml/2006/main">
             <a:pPr algn="l">
+              <a:buNone/>
               <a:defRPr sz="1350" b="1">
                 <a:solidFill>
                   <a:srgbClr val="312D2A"/>
@@ -5531,6 +5486,7 @@
           <a:lstStyle xmlns:a="http://schemas.openxmlformats.org/drawingml/2006/main"/>
           <a:p xmlns:a="http://schemas.openxmlformats.org/drawingml/2006/main">
             <a:pPr algn="l">
+              <a:buNone/>
               <a:defRPr sz="975" b="0">
                 <a:solidFill>
                   <a:srgbClr val="6F6A65"/>
@@ -5543,7 +5499,7 @@
                   <a:srgbClr val="6F6A65"/>
                 </a:solidFill>
               </a:rPr>
-              <a:t>Usa ~/.oci/config, profile e compartment alvo.</a:t>
+              <a:t>Uses ~/.oci/config, profile, and target compartment.</a:t>
             </a:r>
           </a:p>
         </p:txBody>
@@ -5585,6 +5541,7 @@
           <a:lstStyle xmlns:a="http://schemas.openxmlformats.org/drawingml/2006/main"/>
           <a:p xmlns:a="http://schemas.openxmlformats.org/drawingml/2006/main">
             <a:pPr algn="ctr">
+              <a:buNone/>
               <a:defRPr sz="1350" b="1">
                 <a:solidFill>
                   <a:srgbClr val="FFFFFF"/>
@@ -5678,14 +5635,14 @@
       </p:sp>
       <p:pic>
         <p:nvPicPr>
-          <p:cNvPr id="93" name=""/>
+          <p:cNvPr id="241" name=""/>
           <p:cNvPicPr>
             <a:picLocks xmlns:a="http://schemas.openxmlformats.org/drawingml/2006/main" noChangeAspect="1"/>
           </p:cNvPicPr>
           <p:nvPr/>
         </p:nvPicPr>
         <p:blipFill>
-          <a:blip xmlns:r="http://schemas.openxmlformats.org/officeDocument/2006/relationships" xmlns:a="http://schemas.openxmlformats.org/drawingml/2006/main" r:embed="R7d28a6f9642b4a2f"/>
+          <a:blip xmlns:r="http://schemas.openxmlformats.org/officeDocument/2006/relationships" xmlns:a="http://schemas.openxmlformats.org/drawingml/2006/main" r:embed="Ra842024a4bdc4617"/>
           <a:stretch xmlns:a="http://schemas.openxmlformats.org/drawingml/2006/main"/>
         </p:blipFill>
         <p:spPr>
@@ -5731,6 +5688,7 @@
           <a:lstStyle xmlns:a="http://schemas.openxmlformats.org/drawingml/2006/main"/>
           <a:p xmlns:a="http://schemas.openxmlformats.org/drawingml/2006/main">
             <a:pPr algn="l">
+              <a:buNone/>
               <a:defRPr sz="1350" b="1">
                 <a:solidFill>
                   <a:srgbClr val="312D2A"/>
@@ -5743,7 +5701,7 @@
                   <a:srgbClr val="312D2A"/>
                 </a:solidFill>
               </a:rPr>
-              <a:t>Stream secundario</a:t>
+              <a:t>Secondary stream</a:t>
             </a:r>
           </a:p>
         </p:txBody>
@@ -5781,6 +5739,7 @@
           <a:lstStyle xmlns:a="http://schemas.openxmlformats.org/drawingml/2006/main"/>
           <a:p xmlns:a="http://schemas.openxmlformats.org/drawingml/2006/main">
             <a:pPr algn="l">
+              <a:buNone/>
               <a:defRPr sz="975" b="0">
                 <a:solidFill>
                   <a:srgbClr val="6F6A65"/>
@@ -5793,7 +5752,7 @@
                   <a:srgbClr val="6F6A65"/>
                 </a:solidFill>
               </a:rPr>
-              <a:t>Cria ou reutiliza stream principal e DLQ na regiao secundaria.</a:t>
+              <a:t>Creates or reuses primary stream and DLQ in the secondary region.</a:t>
             </a:r>
           </a:p>
         </p:txBody>
@@ -5835,6 +5794,7 @@
           <a:lstStyle xmlns:a="http://schemas.openxmlformats.org/drawingml/2006/main"/>
           <a:p xmlns:a="http://schemas.openxmlformats.org/drawingml/2006/main">
             <a:pPr algn="ctr">
+              <a:buNone/>
               <a:defRPr sz="1350" b="1">
                 <a:solidFill>
                   <a:srgbClr val="FFFFFF"/>
@@ -5928,14 +5888,14 @@
       </p:sp>
       <p:pic>
         <p:nvPicPr>
-          <p:cNvPr id="99" name=""/>
+          <p:cNvPr id="247" name=""/>
           <p:cNvPicPr>
             <a:picLocks xmlns:a="http://schemas.openxmlformats.org/drawingml/2006/main" noChangeAspect="1"/>
           </p:cNvPicPr>
           <p:nvPr/>
         </p:nvPicPr>
         <p:blipFill>
-          <a:blip xmlns:r="http://schemas.openxmlformats.org/officeDocument/2006/relationships" xmlns:a="http://schemas.openxmlformats.org/drawingml/2006/main" r:embed="R39eef6b331f54f39"/>
+          <a:blip xmlns:r="http://schemas.openxmlformats.org/officeDocument/2006/relationships" xmlns:a="http://schemas.openxmlformats.org/drawingml/2006/main" r:embed="R163e66d000d94224"/>
           <a:stretch xmlns:a="http://schemas.openxmlformats.org/drawingml/2006/main"/>
         </p:blipFill>
         <p:spPr>
@@ -5981,6 +5941,7 @@
           <a:lstStyle xmlns:a="http://schemas.openxmlformats.org/drawingml/2006/main"/>
           <a:p xmlns:a="http://schemas.openxmlformats.org/drawingml/2006/main">
             <a:pPr algn="l">
+              <a:buNone/>
               <a:defRPr sz="1350" b="1">
                 <a:solidFill>
                   <a:srgbClr val="312D2A"/>
@@ -5993,7 +5954,7 @@
                   <a:srgbClr val="312D2A"/>
                 </a:solidFill>
               </a:rPr>
-              <a:t>Estado salvo</a:t>
+              <a:t>Saved state</a:t>
             </a:r>
           </a:p>
         </p:txBody>
@@ -6031,6 +5992,7 @@
           <a:lstStyle xmlns:a="http://schemas.openxmlformats.org/drawingml/2006/main"/>
           <a:p xmlns:a="http://schemas.openxmlformats.org/drawingml/2006/main">
             <a:pPr algn="l">
+              <a:buNone/>
               <a:defRPr sz="975" b="0">
                 <a:solidFill>
                   <a:srgbClr val="6F6A65"/>
@@ -6043,7 +6005,7 @@
                   <a:srgbClr val="6F6A65"/>
                 </a:solidFill>
               </a:rPr>
-              <a:t>Guarda endpoint, bootstrap Kafka e OCIDs.</a:t>
+              <a:t>Stores endpoint, Kafka bootstrap, and OCIDs.</a:t>
             </a:r>
           </a:p>
         </p:txBody>
@@ -6085,6 +6047,7 @@
           <a:lstStyle xmlns:a="http://schemas.openxmlformats.org/drawingml/2006/main"/>
           <a:p xmlns:a="http://schemas.openxmlformats.org/drawingml/2006/main">
             <a:pPr algn="ctr">
+              <a:buNone/>
               <a:defRPr sz="1350" b="1">
                 <a:solidFill>
                   <a:srgbClr val="FFFFFF"/>
@@ -6178,14 +6141,14 @@
       </p:sp>
       <p:pic>
         <p:nvPicPr>
-          <p:cNvPr id="105" name=""/>
+          <p:cNvPr id="253" name=""/>
           <p:cNvPicPr>
             <a:picLocks xmlns:a="http://schemas.openxmlformats.org/drawingml/2006/main" noChangeAspect="1"/>
           </p:cNvPicPr>
           <p:nvPr/>
         </p:nvPicPr>
         <p:blipFill>
-          <a:blip xmlns:r="http://schemas.openxmlformats.org/officeDocument/2006/relationships" xmlns:a="http://schemas.openxmlformats.org/drawingml/2006/main" r:embed="R8dde80cc3cc64d9b"/>
+          <a:blip xmlns:r="http://schemas.openxmlformats.org/officeDocument/2006/relationships" xmlns:a="http://schemas.openxmlformats.org/drawingml/2006/main" r:embed="R42a3f603359b47b1"/>
           <a:stretch xmlns:a="http://schemas.openxmlformats.org/drawingml/2006/main"/>
         </p:blipFill>
         <p:spPr>
@@ -6231,6 +6194,7 @@
           <a:lstStyle xmlns:a="http://schemas.openxmlformats.org/drawingml/2006/main"/>
           <a:p xmlns:a="http://schemas.openxmlformats.org/drawingml/2006/main">
             <a:pPr algn="l">
+              <a:buNone/>
               <a:defRPr sz="1350" b="1">
                 <a:solidFill>
                   <a:srgbClr val="312D2A"/>
@@ -6243,7 +6207,7 @@
                   <a:srgbClr val="312D2A"/>
                 </a:solidFill>
               </a:rPr>
-              <a:t>Clients reiniciados</a:t>
+              <a:t>Clients restarted</a:t>
             </a:r>
           </a:p>
         </p:txBody>
@@ -6281,6 +6245,7 @@
           <a:lstStyle xmlns:a="http://schemas.openxmlformats.org/drawingml/2006/main"/>
           <a:p xmlns:a="http://schemas.openxmlformats.org/drawingml/2006/main">
             <a:pPr algn="l">
+              <a:buNone/>
               <a:defRPr sz="975" b="0">
                 <a:solidFill>
                   <a:srgbClr val="6F6A65"/>
@@ -6293,7 +6258,7 @@
                   <a:srgbClr val="6F6A65"/>
                 </a:solidFill>
               </a:rPr>
-              <a:t>Factories atualizadas e listeners Kafka reiniciados.</a:t>
+              <a:t>Factories updated and Kafka listeners restarted.</a:t>
             </a:r>
           </a:p>
         </p:txBody>
@@ -6335,6 +6300,7 @@
           <a:lstStyle xmlns:a="http://schemas.openxmlformats.org/drawingml/2006/main"/>
           <a:p xmlns:a="http://schemas.openxmlformats.org/drawingml/2006/main">
             <a:pPr algn="ctr">
+              <a:buNone/>
               <a:defRPr sz="1350" b="1">
                 <a:solidFill>
                   <a:srgbClr val="FFFFFF"/>
@@ -6354,7 +6320,7 @@
       </p:sp>
       <p:cxnSp>
         <p:nvCxnSpPr>
-          <p:cNvPr id="109" name=""/>
+          <p:cNvPr id="257" name=""/>
           <p:cNvCxnSpPr>
             <a:stCxn xmlns:a="http://schemas.openxmlformats.org/drawingml/2006/main" id="4" idx="3"/>
             <a:endCxn xmlns:a="http://schemas.openxmlformats.org/drawingml/2006/main" id="10" idx="1"/>
@@ -6380,7 +6346,7 @@
       </p:cxnSp>
       <p:cxnSp>
         <p:nvCxnSpPr>
-          <p:cNvPr id="110" name=""/>
+          <p:cNvPr id="258" name=""/>
           <p:cNvCxnSpPr>
             <a:stCxn xmlns:a="http://schemas.openxmlformats.org/drawingml/2006/main" id="10" idx="3"/>
             <a:endCxn xmlns:a="http://schemas.openxmlformats.org/drawingml/2006/main" id="16" idx="1"/>
@@ -6406,7 +6372,7 @@
       </p:cxnSp>
       <p:cxnSp>
         <p:nvCxnSpPr>
-          <p:cNvPr id="111" name=""/>
+          <p:cNvPr id="259" name=""/>
           <p:cNvCxnSpPr>
             <a:stCxn xmlns:a="http://schemas.openxmlformats.org/drawingml/2006/main" id="16" idx="3"/>
             <a:endCxn xmlns:a="http://schemas.openxmlformats.org/drawingml/2006/main" id="22" idx="1"/>
@@ -6432,7 +6398,7 @@
       </p:cxnSp>
       <p:cxnSp>
         <p:nvCxnSpPr>
-          <p:cNvPr id="112" name=""/>
+          <p:cNvPr id="260" name=""/>
           <p:cNvCxnSpPr>
             <a:stCxn xmlns:a="http://schemas.openxmlformats.org/drawingml/2006/main" id="22" idx="3"/>
             <a:endCxn xmlns:a="http://schemas.openxmlformats.org/drawingml/2006/main" id="28" idx="1"/>
@@ -6458,7 +6424,7 @@
       </p:cxnSp>
       <p:cxnSp>
         <p:nvCxnSpPr>
-          <p:cNvPr id="113" name=""/>
+          <p:cNvPr id="261" name=""/>
           <p:cNvCxnSpPr>
             <a:stCxn xmlns:a="http://schemas.openxmlformats.org/drawingml/2006/main" id="28" idx="3"/>
             <a:endCxn xmlns:a="http://schemas.openxmlformats.org/drawingml/2006/main" id="34" idx="1"/>
@@ -6550,6 +6516,7 @@
           <a:lstStyle xmlns:a="http://schemas.openxmlformats.org/drawingml/2006/main"/>
           <a:p xmlns:a="http://schemas.openxmlformats.org/drawingml/2006/main">
             <a:pPr algn="l">
+              <a:buNone/>
               <a:defRPr sz="1575" b="1">
                 <a:solidFill>
                   <a:srgbClr val="17404A"/>
@@ -6562,7 +6529,7 @@
                   <a:srgbClr val="17404A"/>
                 </a:solidFill>
               </a:rPr>
-              <a:t>Resultado operacional</a:t>
+              <a:t>Operational result</a:t>
             </a:r>
           </a:p>
         </p:txBody>
@@ -6600,6 +6567,7 @@
           <a:lstStyle xmlns:a="http://schemas.openxmlformats.org/drawingml/2006/main"/>
           <a:p xmlns:a="http://schemas.openxmlformats.org/drawingml/2006/main">
             <a:pPr algn="l">
+              <a:buNone/>
               <a:defRPr sz="1050" b="0">
                 <a:solidFill>
                   <a:srgbClr val="6F6A65"/>
@@ -6612,7 +6580,7 @@
                   <a:srgbClr val="6F6A65"/>
                 </a:solidFill>
               </a:rPr>
-              <a:t>A aplicacao passa a apostar/publicar e consumir no novo stream salvo.</a:t>
+              <a:t>The application starts publishing and consuming from the saved new stream.</a:t>
             </a:r>
           </a:p>
         </p:txBody>
@@ -6693,14 +6661,14 @@
       </p:sp>
       <p:pic>
         <p:nvPicPr>
-          <p:cNvPr id="119" name=""/>
+          <p:cNvPr id="267" name=""/>
           <p:cNvPicPr>
             <a:picLocks xmlns:a="http://schemas.openxmlformats.org/drawingml/2006/main" noChangeAspect="1"/>
           </p:cNvPicPr>
           <p:nvPr/>
         </p:nvPicPr>
         <p:blipFill>
-          <a:blip xmlns:r="http://schemas.openxmlformats.org/officeDocument/2006/relationships" xmlns:a="http://schemas.openxmlformats.org/drawingml/2006/main" r:embed="Raa71483d29584573"/>
+          <a:blip xmlns:r="http://schemas.openxmlformats.org/officeDocument/2006/relationships" xmlns:a="http://schemas.openxmlformats.org/drawingml/2006/main" r:embed="R2e136c3cd0564548"/>
           <a:stretch xmlns:a="http://schemas.openxmlformats.org/drawingml/2006/main"/>
         </p:blipFill>
         <p:spPr>
@@ -6746,6 +6714,7 @@
           <a:lstStyle xmlns:a="http://schemas.openxmlformats.org/drawingml/2006/main"/>
           <a:p xmlns:a="http://schemas.openxmlformats.org/drawingml/2006/main">
             <a:pPr algn="l">
+              <a:buNone/>
               <a:defRPr sz="1350" b="1">
                 <a:solidFill>
                   <a:srgbClr val="312D2A"/>
@@ -6796,6 +6765,7 @@
           <a:lstStyle xmlns:a="http://schemas.openxmlformats.org/drawingml/2006/main"/>
           <a:p xmlns:a="http://schemas.openxmlformats.org/drawingml/2006/main">
             <a:pPr algn="l">
+              <a:buNone/>
               <a:defRPr sz="975" b="0">
                 <a:solidFill>
                   <a:srgbClr val="6F6A65"/>
@@ -6808,7 +6778,7 @@
                   <a:srgbClr val="6F6A65"/>
                 </a:solidFill>
               </a:rPr>
-              <a:t>Reenvia a mensagem que disparou o failover usando o novo bootstrap.</a:t>
+              <a:t>Resends the message that triggered failover using the new bootstrap.</a:t>
             </a:r>
           </a:p>
         </p:txBody>
@@ -6889,14 +6859,14 @@
       </p:sp>
       <p:pic>
         <p:nvPicPr>
-          <p:cNvPr id="124" name=""/>
+          <p:cNvPr id="272" name=""/>
           <p:cNvPicPr>
             <a:picLocks xmlns:a="http://schemas.openxmlformats.org/drawingml/2006/main" noChangeAspect="1"/>
           </p:cNvPicPr>
           <p:nvPr/>
         </p:nvPicPr>
         <p:blipFill>
-          <a:blip xmlns:r="http://schemas.openxmlformats.org/officeDocument/2006/relationships" xmlns:a="http://schemas.openxmlformats.org/drawingml/2006/main" r:embed="R3cd3faaefba24050"/>
+          <a:blip xmlns:r="http://schemas.openxmlformats.org/officeDocument/2006/relationships" xmlns:a="http://schemas.openxmlformats.org/drawingml/2006/main" r:embed="Rcbf58929b7bb4bed"/>
           <a:stretch xmlns:a="http://schemas.openxmlformats.org/drawingml/2006/main"/>
         </p:blipFill>
         <p:spPr>
@@ -6942,6 +6912,7 @@
           <a:lstStyle xmlns:a="http://schemas.openxmlformats.org/drawingml/2006/main"/>
           <a:p xmlns:a="http://schemas.openxmlformats.org/drawingml/2006/main">
             <a:pPr algn="l">
+              <a:buNone/>
               <a:defRPr sz="1350" b="1">
                 <a:solidFill>
                   <a:srgbClr val="312D2A"/>
@@ -6954,7 +6925,7 @@
                   <a:srgbClr val="312D2A"/>
                 </a:solidFill>
               </a:rPr>
-              <a:t>OCI Streaming secundario</a:t>
+              <a:t>Secondary OCI Streaming</a:t>
             </a:r>
           </a:p>
         </p:txBody>
@@ -6992,6 +6963,7 @@
           <a:lstStyle xmlns:a="http://schemas.openxmlformats.org/drawingml/2006/main"/>
           <a:p xmlns:a="http://schemas.openxmlformats.org/drawingml/2006/main">
             <a:pPr algn="l">
+              <a:buNone/>
               <a:defRPr sz="975" b="0">
                 <a:solidFill>
                   <a:srgbClr val="6F6A65"/>
@@ -7004,7 +6976,7 @@
                   <a:srgbClr val="6F6A65"/>
                 </a:solidFill>
               </a:rPr>
-              <a:t>Topico logico mantido ou nome secundario configurado.</a:t>
+              <a:t>Logical topic preserved or configured secondary name.</a:t>
             </a:r>
           </a:p>
         </p:txBody>
@@ -7085,14 +7057,14 @@
       </p:sp>
       <p:pic>
         <p:nvPicPr>
-          <p:cNvPr id="129" name=""/>
+          <p:cNvPr id="277" name=""/>
           <p:cNvPicPr>
             <a:picLocks xmlns:a="http://schemas.openxmlformats.org/drawingml/2006/main" noChangeAspect="1"/>
           </p:cNvPicPr>
           <p:nvPr/>
         </p:nvPicPr>
         <p:blipFill>
-          <a:blip xmlns:r="http://schemas.openxmlformats.org/officeDocument/2006/relationships" xmlns:a="http://schemas.openxmlformats.org/drawingml/2006/main" r:embed="Rcb3a8af90dcb4397"/>
+          <a:blip xmlns:r="http://schemas.openxmlformats.org/officeDocument/2006/relationships" xmlns:a="http://schemas.openxmlformats.org/drawingml/2006/main" r:embed="R0165f6cf920e44bf"/>
           <a:stretch xmlns:a="http://schemas.openxmlformats.org/drawingml/2006/main"/>
         </p:blipFill>
         <p:spPr>
@@ -7138,6 +7110,7 @@
           <a:lstStyle xmlns:a="http://schemas.openxmlformats.org/drawingml/2006/main"/>
           <a:p xmlns:a="http://schemas.openxmlformats.org/drawingml/2006/main">
             <a:pPr algn="l">
+              <a:buNone/>
               <a:defRPr sz="1350" b="1">
                 <a:solidFill>
                   <a:srgbClr val="312D2A"/>
@@ -7150,7 +7123,7 @@
                   <a:srgbClr val="312D2A"/>
                 </a:solidFill>
               </a:rPr>
-              <a:t>Consumer batch</a:t>
+              <a:t>Batch consumer</a:t>
             </a:r>
           </a:p>
         </p:txBody>
@@ -7188,6 +7161,7 @@
           <a:lstStyle xmlns:a="http://schemas.openxmlformats.org/drawingml/2006/main"/>
           <a:p xmlns:a="http://schemas.openxmlformats.org/drawingml/2006/main">
             <a:pPr algn="l">
+              <a:buNone/>
               <a:defRPr sz="975" b="0">
                 <a:solidFill>
                   <a:srgbClr val="6F6A65"/>
@@ -7200,14 +7174,14 @@
                   <a:srgbClr val="6F6A65"/>
                 </a:solidFill>
               </a:rPr>
-              <a:t>Listener reiniciado consome do endpoint persistido e commita apos sucesso.</a:t>
+              <a:t>Restarted listener consumes from the persisted endpoint and commits after success.</a:t>
             </a:r>
           </a:p>
         </p:txBody>
       </p:sp>
       <p:cxnSp>
         <p:nvCxnSpPr>
-          <p:cNvPr id="132" name=""/>
+          <p:cNvPr id="280" name=""/>
           <p:cNvCxnSpPr>
             <a:stCxn xmlns:a="http://schemas.openxmlformats.org/drawingml/2006/main" id="48" idx="3"/>
             <a:endCxn xmlns:a="http://schemas.openxmlformats.org/drawingml/2006/main" id="53" idx="1"/>
@@ -7264,6 +7238,7 @@
           <a:lstStyle xmlns:a="http://schemas.openxmlformats.org/drawingml/2006/main"/>
           <a:p xmlns:a="http://schemas.openxmlformats.org/drawingml/2006/main">
             <a:pPr algn="ctr">
+              <a:buNone/>
               <a:defRPr sz="900" b="1">
                 <a:solidFill>
                   <a:srgbClr val="2C5967"/>
@@ -7283,7 +7258,7 @@
       </p:sp>
       <p:cxnSp>
         <p:nvCxnSpPr>
-          <p:cNvPr id="134" name=""/>
+          <p:cNvPr id="282" name=""/>
           <p:cNvCxnSpPr>
             <a:stCxn xmlns:a="http://schemas.openxmlformats.org/drawingml/2006/main" id="53" idx="3"/>
             <a:endCxn xmlns:a="http://schemas.openxmlformats.org/drawingml/2006/main" id="58" idx="1"/>
@@ -7340,6 +7315,7 @@
           <a:lstStyle xmlns:a="http://schemas.openxmlformats.org/drawingml/2006/main"/>
           <a:p xmlns:a="http://schemas.openxmlformats.org/drawingml/2006/main">
             <a:pPr algn="ctr">
+              <a:buNone/>
               <a:defRPr sz="900" b="1">
                 <a:solidFill>
                   <a:srgbClr val="759C6C"/>
@@ -7390,6 +7366,7 @@
           <a:lstStyle xmlns:a="http://schemas.openxmlformats.org/drawingml/2006/main"/>
           <a:p xmlns:a="http://schemas.openxmlformats.org/drawingml/2006/main">
             <a:pPr algn="l">
+              <a:buNone/>
               <a:defRPr sz="1200" b="1">
                 <a:solidFill>
                   <a:srgbClr val="312D2A"/>
@@ -7402,7 +7379,7 @@
                   <a:srgbClr val="312D2A"/>
                 </a:solidFill>
               </a:rPr>
-              <a:t>Arquivo persistido</a:t>
+              <a:t>Persisted file</a:t>
             </a:r>
           </a:p>
         </p:txBody>
@@ -7440,6 +7417,7 @@
           <a:lstStyle xmlns:a="http://schemas.openxmlformats.org/drawingml/2006/main"/>
           <a:p xmlns:a="http://schemas.openxmlformats.org/drawingml/2006/main">
             <a:pPr algn="l">
+              <a:buNone/>
               <a:defRPr sz="1050" b="0">
                 <a:solidFill>
                   <a:srgbClr val="6F6A65"/>
@@ -7490,6 +7468,7 @@
           <a:lstStyle xmlns:a="http://schemas.openxmlformats.org/drawingml/2006/main"/>
           <a:p xmlns:a="http://schemas.openxmlformats.org/drawingml/2006/main">
             <a:pPr algn="r">
+              <a:buNone/>
               <a:defRPr sz="1050" b="1">
                 <a:solidFill>
                   <a:srgbClr val="C74634"/>
@@ -7502,7 +7481,7 @@
                   <a:srgbClr val="C74634"/>
                 </a:solidFill>
               </a:rPr>
-              <a:t>Retry + DLQ continuam ativos depois da troca.</a:t>
+              <a:t>Retry + DLQ remain active after the switch.</a:t>
             </a:r>
           </a:p>
         </p:txBody>

</xml_diff>